<commit_message>
docs(ppt): add concept visuals to submission deck, fix inline-run bug in extended deck, refresh previews
Co-authored-by: arena-agent <297053741+arena-agent@users.noreply.github.com>
</commit_message>
<xml_diff>
--- a/docs/ppt/CAPACITY_CONNECT_SIH2026_26075.pptx
+++ b/docs/ppt/CAPACITY_CONNECT_SIH2026_26075.pptx
@@ -11809,16 +11809,6 @@
               </a:rPr>
               <a:t>Acceptance criterion: </a:t>
             </a:r>
-          </a:p>
-          <a:p>
-            <a:pPr algn="l">
-              <a:lnSpc>
-                <a:spcPct val="105000"/>
-              </a:lnSpc>
-              <a:spcAft>
-                <a:spcPts val="400"/>
-              </a:spcAft>
-            </a:pPr>
             <a:r>
               <a:rPr sz="1100" b="0">
                 <a:solidFill>
@@ -13061,16 +13051,6 @@
               </a:rPr>
               <a:t>Viability: </a:t>
             </a:r>
-          </a:p>
-          <a:p>
-            <a:pPr algn="l">
-              <a:lnSpc>
-                <a:spcPct val="105000"/>
-              </a:lnSpc>
-              <a:spcAft>
-                <a:spcPts val="400"/>
-              </a:spcAft>
-            </a:pPr>
             <a:r>
               <a:rPr sz="1050" b="0">
                 <a:solidFill>
@@ -16248,16 +16228,6 @@
               </a:rPr>
               <a:t>Definition of Done: </a:t>
             </a:r>
-          </a:p>
-          <a:p>
-            <a:pPr algn="l">
-              <a:lnSpc>
-                <a:spcPct val="105000"/>
-              </a:lnSpc>
-              <a:spcAft>
-                <a:spcPts val="400"/>
-              </a:spcAft>
-            </a:pPr>
             <a:r>
               <a:rPr sz="1050" b="0">
                 <a:solidFill>
@@ -16585,16 +16555,6 @@
               </a:rPr>
               <a:t>✓  </a:t>
             </a:r>
-          </a:p>
-          <a:p>
-            <a:pPr algn="l">
-              <a:lnSpc>
-                <a:spcPct val="105000"/>
-              </a:lnSpc>
-              <a:spcAft>
-                <a:spcPts val="400"/>
-              </a:spcAft>
-            </a:pPr>
             <a:r>
               <a:rPr sz="1200" b="0">
                 <a:solidFill>
@@ -16646,16 +16606,6 @@
               </a:rPr>
               <a:t>✓  </a:t>
             </a:r>
-          </a:p>
-          <a:p>
-            <a:pPr algn="l">
-              <a:lnSpc>
-                <a:spcPct val="105000"/>
-              </a:lnSpc>
-              <a:spcAft>
-                <a:spcPts val="400"/>
-              </a:spcAft>
-            </a:pPr>
             <a:r>
               <a:rPr sz="1200" b="0">
                 <a:solidFill>
@@ -16707,16 +16657,6 @@
               </a:rPr>
               <a:t>✓  </a:t>
             </a:r>
-          </a:p>
-          <a:p>
-            <a:pPr algn="l">
-              <a:lnSpc>
-                <a:spcPct val="105000"/>
-              </a:lnSpc>
-              <a:spcAft>
-                <a:spcPts val="400"/>
-              </a:spcAft>
-            </a:pPr>
             <a:r>
               <a:rPr sz="1200" b="0">
                 <a:solidFill>
@@ -16768,16 +16708,6 @@
               </a:rPr>
               <a:t>✓  </a:t>
             </a:r>
-          </a:p>
-          <a:p>
-            <a:pPr algn="l">
-              <a:lnSpc>
-                <a:spcPct val="105000"/>
-              </a:lnSpc>
-              <a:spcAft>
-                <a:spcPts val="400"/>
-              </a:spcAft>
-            </a:pPr>
             <a:r>
               <a:rPr sz="1200" b="0">
                 <a:solidFill>
@@ -16829,16 +16759,6 @@
               </a:rPr>
               <a:t>✓  </a:t>
             </a:r>
-          </a:p>
-          <a:p>
-            <a:pPr algn="l">
-              <a:lnSpc>
-                <a:spcPct val="105000"/>
-              </a:lnSpc>
-              <a:spcAft>
-                <a:spcPts val="400"/>
-              </a:spcAft>
-            </a:pPr>
             <a:r>
               <a:rPr sz="1200" b="0">
                 <a:solidFill>
@@ -20231,16 +20151,6 @@
               </a:rPr>
               <a:t>▸  </a:t>
             </a:r>
-          </a:p>
-          <a:p>
-            <a:pPr algn="l">
-              <a:lnSpc>
-                <a:spcPct val="105000"/>
-              </a:lnSpc>
-              <a:spcAft>
-                <a:spcPts val="400"/>
-              </a:spcAft>
-            </a:pPr>
             <a:r>
               <a:rPr sz="1100" b="0">
                 <a:solidFill>
@@ -20292,16 +20202,6 @@
               </a:rPr>
               <a:t>▸  </a:t>
             </a:r>
-          </a:p>
-          <a:p>
-            <a:pPr algn="l">
-              <a:lnSpc>
-                <a:spcPct val="105000"/>
-              </a:lnSpc>
-              <a:spcAft>
-                <a:spcPts val="400"/>
-              </a:spcAft>
-            </a:pPr>
             <a:r>
               <a:rPr sz="1100" b="0">
                 <a:solidFill>
@@ -20353,16 +20253,6 @@
               </a:rPr>
               <a:t>▸  </a:t>
             </a:r>
-          </a:p>
-          <a:p>
-            <a:pPr algn="l">
-              <a:lnSpc>
-                <a:spcPct val="105000"/>
-              </a:lnSpc>
-              <a:spcAft>
-                <a:spcPts val="400"/>
-              </a:spcAft>
-            </a:pPr>
             <a:r>
               <a:rPr sz="1100" b="0">
                 <a:solidFill>
@@ -20414,16 +20304,6 @@
               </a:rPr>
               <a:t>▸  </a:t>
             </a:r>
-          </a:p>
-          <a:p>
-            <a:pPr algn="l">
-              <a:lnSpc>
-                <a:spcPct val="105000"/>
-              </a:lnSpc>
-              <a:spcAft>
-                <a:spcPts val="400"/>
-              </a:spcAft>
-            </a:pPr>
             <a:r>
               <a:rPr sz="1100" b="0">
                 <a:solidFill>
@@ -22765,16 +22645,6 @@
               </a:rPr>
               <a:t>· </a:t>
             </a:r>
-          </a:p>
-          <a:p>
-            <a:pPr algn="l">
-              <a:lnSpc>
-                <a:spcPct val="110000"/>
-              </a:lnSpc>
-              <a:spcAft>
-                <a:spcPts val="400"/>
-              </a:spcAft>
-            </a:pPr>
             <a:r>
               <a:rPr sz="1050" b="0">
                 <a:solidFill>
@@ -22826,16 +22696,6 @@
               </a:rPr>
               <a:t>· </a:t>
             </a:r>
-          </a:p>
-          <a:p>
-            <a:pPr algn="l">
-              <a:lnSpc>
-                <a:spcPct val="110000"/>
-              </a:lnSpc>
-              <a:spcAft>
-                <a:spcPts val="400"/>
-              </a:spcAft>
-            </a:pPr>
             <a:r>
               <a:rPr sz="1050" b="0">
                 <a:solidFill>
@@ -22887,16 +22747,6 @@
               </a:rPr>
               <a:t>· </a:t>
             </a:r>
-          </a:p>
-          <a:p>
-            <a:pPr algn="l">
-              <a:lnSpc>
-                <a:spcPct val="110000"/>
-              </a:lnSpc>
-              <a:spcAft>
-                <a:spcPts val="400"/>
-              </a:spcAft>
-            </a:pPr>
             <a:r>
               <a:rPr sz="1050" b="0">
                 <a:solidFill>
@@ -22948,16 +22798,6 @@
               </a:rPr>
               <a:t>· </a:t>
             </a:r>
-          </a:p>
-          <a:p>
-            <a:pPr algn="l">
-              <a:lnSpc>
-                <a:spcPct val="110000"/>
-              </a:lnSpc>
-              <a:spcAft>
-                <a:spcPts val="400"/>
-              </a:spcAft>
-            </a:pPr>
             <a:r>
               <a:rPr sz="1050" b="0">
                 <a:solidFill>
@@ -23009,16 +22849,6 @@
               </a:rPr>
               <a:t>· </a:t>
             </a:r>
-          </a:p>
-          <a:p>
-            <a:pPr algn="l">
-              <a:lnSpc>
-                <a:spcPct val="110000"/>
-              </a:lnSpc>
-              <a:spcAft>
-                <a:spcPts val="400"/>
-              </a:spcAft>
-            </a:pPr>
             <a:r>
               <a:rPr sz="1050" b="0">
                 <a:solidFill>
@@ -23070,16 +22900,6 @@
               </a:rPr>
               <a:t>· </a:t>
             </a:r>
-          </a:p>
-          <a:p>
-            <a:pPr algn="l">
-              <a:lnSpc>
-                <a:spcPct val="110000"/>
-              </a:lnSpc>
-              <a:spcAft>
-                <a:spcPts val="400"/>
-              </a:spcAft>
-            </a:pPr>
             <a:r>
               <a:rPr sz="1050" b="0">
                 <a:solidFill>
@@ -23131,16 +22951,6 @@
               </a:rPr>
               <a:t>· </a:t>
             </a:r>
-          </a:p>
-          <a:p>
-            <a:pPr algn="l">
-              <a:lnSpc>
-                <a:spcPct val="110000"/>
-              </a:lnSpc>
-              <a:spcAft>
-                <a:spcPts val="400"/>
-              </a:spcAft>
-            </a:pPr>
             <a:r>
               <a:rPr sz="1050" b="0">
                 <a:solidFill>
@@ -23192,16 +23002,6 @@
               </a:rPr>
               <a:t>· </a:t>
             </a:r>
-          </a:p>
-          <a:p>
-            <a:pPr algn="l">
-              <a:lnSpc>
-                <a:spcPct val="110000"/>
-              </a:lnSpc>
-              <a:spcAft>
-                <a:spcPts val="400"/>
-              </a:spcAft>
-            </a:pPr>
             <a:r>
               <a:rPr sz="1050" b="0">
                 <a:solidFill>
@@ -23387,16 +23187,6 @@
               </a:rPr>
               <a:t>· </a:t>
             </a:r>
-          </a:p>
-          <a:p>
-            <a:pPr algn="l">
-              <a:lnSpc>
-                <a:spcPct val="110000"/>
-              </a:lnSpc>
-              <a:spcAft>
-                <a:spcPts val="400"/>
-              </a:spcAft>
-            </a:pPr>
             <a:r>
               <a:rPr sz="1050" b="0">
                 <a:solidFill>
@@ -23448,16 +23238,6 @@
               </a:rPr>
               <a:t>· </a:t>
             </a:r>
-          </a:p>
-          <a:p>
-            <a:pPr algn="l">
-              <a:lnSpc>
-                <a:spcPct val="110000"/>
-              </a:lnSpc>
-              <a:spcAft>
-                <a:spcPts val="400"/>
-              </a:spcAft>
-            </a:pPr>
             <a:r>
               <a:rPr sz="1050" b="0">
                 <a:solidFill>
@@ -23509,16 +23289,6 @@
               </a:rPr>
               <a:t>· </a:t>
             </a:r>
-          </a:p>
-          <a:p>
-            <a:pPr algn="l">
-              <a:lnSpc>
-                <a:spcPct val="110000"/>
-              </a:lnSpc>
-              <a:spcAft>
-                <a:spcPts val="400"/>
-              </a:spcAft>
-            </a:pPr>
             <a:r>
               <a:rPr sz="1050" b="0">
                 <a:solidFill>
@@ -23570,16 +23340,6 @@
               </a:rPr>
               <a:t>· </a:t>
             </a:r>
-          </a:p>
-          <a:p>
-            <a:pPr algn="l">
-              <a:lnSpc>
-                <a:spcPct val="110000"/>
-              </a:lnSpc>
-              <a:spcAft>
-                <a:spcPts val="400"/>
-              </a:spcAft>
-            </a:pPr>
             <a:r>
               <a:rPr sz="1050" b="0">
                 <a:solidFill>
@@ -23631,16 +23391,6 @@
               </a:rPr>
               <a:t>· </a:t>
             </a:r>
-          </a:p>
-          <a:p>
-            <a:pPr algn="l">
-              <a:lnSpc>
-                <a:spcPct val="110000"/>
-              </a:lnSpc>
-              <a:spcAft>
-                <a:spcPts val="400"/>
-              </a:spcAft>
-            </a:pPr>
             <a:r>
               <a:rPr sz="1050" b="0">
                 <a:solidFill>
@@ -23692,16 +23442,6 @@
               </a:rPr>
               <a:t>· </a:t>
             </a:r>
-          </a:p>
-          <a:p>
-            <a:pPr algn="l">
-              <a:lnSpc>
-                <a:spcPct val="110000"/>
-              </a:lnSpc>
-              <a:spcAft>
-                <a:spcPts val="400"/>
-              </a:spcAft>
-            </a:pPr>
             <a:r>
               <a:rPr sz="1050" b="0">
                 <a:solidFill>
@@ -23753,16 +23493,6 @@
               </a:rPr>
               <a:t>· </a:t>
             </a:r>
-          </a:p>
-          <a:p>
-            <a:pPr algn="l">
-              <a:lnSpc>
-                <a:spcPct val="110000"/>
-              </a:lnSpc>
-              <a:spcAft>
-                <a:spcPts val="400"/>
-              </a:spcAft>
-            </a:pPr>
             <a:r>
               <a:rPr sz="1050" b="0">
                 <a:solidFill>
@@ -23948,16 +23678,6 @@
               </a:rPr>
               <a:t>· </a:t>
             </a:r>
-          </a:p>
-          <a:p>
-            <a:pPr algn="l">
-              <a:lnSpc>
-                <a:spcPct val="110000"/>
-              </a:lnSpc>
-              <a:spcAft>
-                <a:spcPts val="400"/>
-              </a:spcAft>
-            </a:pPr>
             <a:r>
               <a:rPr sz="1050" b="0">
                 <a:solidFill>
@@ -24009,16 +23729,6 @@
               </a:rPr>
               <a:t>· </a:t>
             </a:r>
-          </a:p>
-          <a:p>
-            <a:pPr algn="l">
-              <a:lnSpc>
-                <a:spcPct val="110000"/>
-              </a:lnSpc>
-              <a:spcAft>
-                <a:spcPts val="400"/>
-              </a:spcAft>
-            </a:pPr>
             <a:r>
               <a:rPr sz="1050" b="0">
                 <a:solidFill>
@@ -24070,16 +23780,6 @@
               </a:rPr>
               <a:t>· </a:t>
             </a:r>
-          </a:p>
-          <a:p>
-            <a:pPr algn="l">
-              <a:lnSpc>
-                <a:spcPct val="110000"/>
-              </a:lnSpc>
-              <a:spcAft>
-                <a:spcPts val="400"/>
-              </a:spcAft>
-            </a:pPr>
             <a:r>
               <a:rPr sz="1050" b="0">
                 <a:solidFill>
@@ -24131,16 +23831,6 @@
               </a:rPr>
               <a:t>· </a:t>
             </a:r>
-          </a:p>
-          <a:p>
-            <a:pPr algn="l">
-              <a:lnSpc>
-                <a:spcPct val="110000"/>
-              </a:lnSpc>
-              <a:spcAft>
-                <a:spcPts val="400"/>
-              </a:spcAft>
-            </a:pPr>
             <a:r>
               <a:rPr sz="1050" b="0">
                 <a:solidFill>
@@ -24192,16 +23882,6 @@
               </a:rPr>
               <a:t>· </a:t>
             </a:r>
-          </a:p>
-          <a:p>
-            <a:pPr algn="l">
-              <a:lnSpc>
-                <a:spcPct val="110000"/>
-              </a:lnSpc>
-              <a:spcAft>
-                <a:spcPts val="400"/>
-              </a:spcAft>
-            </a:pPr>
             <a:r>
               <a:rPr sz="1050" b="0">
                 <a:solidFill>
@@ -24253,16 +23933,6 @@
               </a:rPr>
               <a:t>· </a:t>
             </a:r>
-          </a:p>
-          <a:p>
-            <a:pPr algn="l">
-              <a:lnSpc>
-                <a:spcPct val="110000"/>
-              </a:lnSpc>
-              <a:spcAft>
-                <a:spcPts val="400"/>
-              </a:spcAft>
-            </a:pPr>
             <a:r>
               <a:rPr sz="1050" b="0">
                 <a:solidFill>
@@ -24314,16 +23984,6 @@
               </a:rPr>
               <a:t>· </a:t>
             </a:r>
-          </a:p>
-          <a:p>
-            <a:pPr algn="l">
-              <a:lnSpc>
-                <a:spcPct val="110000"/>
-              </a:lnSpc>
-              <a:spcAft>
-                <a:spcPts val="400"/>
-              </a:spcAft>
-            </a:pPr>
             <a:r>
               <a:rPr sz="1050" b="0">
                 <a:solidFill>
@@ -24509,16 +24169,6 @@
               </a:rPr>
               <a:t>· </a:t>
             </a:r>
-          </a:p>
-          <a:p>
-            <a:pPr algn="l">
-              <a:lnSpc>
-                <a:spcPct val="110000"/>
-              </a:lnSpc>
-              <a:spcAft>
-                <a:spcPts val="400"/>
-              </a:spcAft>
-            </a:pPr>
             <a:r>
               <a:rPr sz="1050" b="0">
                 <a:solidFill>
@@ -24570,16 +24220,6 @@
               </a:rPr>
               <a:t>· </a:t>
             </a:r>
-          </a:p>
-          <a:p>
-            <a:pPr algn="l">
-              <a:lnSpc>
-                <a:spcPct val="110000"/>
-              </a:lnSpc>
-              <a:spcAft>
-                <a:spcPts val="400"/>
-              </a:spcAft>
-            </a:pPr>
             <a:r>
               <a:rPr sz="1050" b="0">
                 <a:solidFill>
@@ -24631,16 +24271,6 @@
               </a:rPr>
               <a:t>· </a:t>
             </a:r>
-          </a:p>
-          <a:p>
-            <a:pPr algn="l">
-              <a:lnSpc>
-                <a:spcPct val="110000"/>
-              </a:lnSpc>
-              <a:spcAft>
-                <a:spcPts val="400"/>
-              </a:spcAft>
-            </a:pPr>
             <a:r>
               <a:rPr sz="1050" b="0">
                 <a:solidFill>
@@ -24692,16 +24322,6 @@
               </a:rPr>
               <a:t>· </a:t>
             </a:r>
-          </a:p>
-          <a:p>
-            <a:pPr algn="l">
-              <a:lnSpc>
-                <a:spcPct val="110000"/>
-              </a:lnSpc>
-              <a:spcAft>
-                <a:spcPts val="400"/>
-              </a:spcAft>
-            </a:pPr>
             <a:r>
               <a:rPr sz="1050" b="0">
                 <a:solidFill>
@@ -24753,16 +24373,6 @@
               </a:rPr>
               <a:t>· </a:t>
             </a:r>
-          </a:p>
-          <a:p>
-            <a:pPr algn="l">
-              <a:lnSpc>
-                <a:spcPct val="110000"/>
-              </a:lnSpc>
-              <a:spcAft>
-                <a:spcPts val="400"/>
-              </a:spcAft>
-            </a:pPr>
             <a:r>
               <a:rPr sz="1050" b="0">
                 <a:solidFill>
@@ -24814,16 +24424,6 @@
               </a:rPr>
               <a:t>· </a:t>
             </a:r>
-          </a:p>
-          <a:p>
-            <a:pPr algn="l">
-              <a:lnSpc>
-                <a:spcPct val="110000"/>
-              </a:lnSpc>
-              <a:spcAft>
-                <a:spcPts val="400"/>
-              </a:spcAft>
-            </a:pPr>
             <a:r>
               <a:rPr sz="1050" b="0">
                 <a:solidFill>
@@ -24875,16 +24475,6 @@
               </a:rPr>
               <a:t>· </a:t>
             </a:r>
-          </a:p>
-          <a:p>
-            <a:pPr algn="l">
-              <a:lnSpc>
-                <a:spcPct val="110000"/>
-              </a:lnSpc>
-              <a:spcAft>
-                <a:spcPts val="400"/>
-              </a:spcAft>
-            </a:pPr>
             <a:r>
               <a:rPr sz="1050" b="0">
                 <a:solidFill>
@@ -24984,16 +24574,6 @@
               </a:rPr>
               <a:t>Targets: </a:t>
             </a:r>
-          </a:p>
-          <a:p>
-            <a:pPr algn="l">
-              <a:lnSpc>
-                <a:spcPct val="120000"/>
-              </a:lnSpc>
-              <a:spcAft>
-                <a:spcPts val="400"/>
-              </a:spcAft>
-            </a:pPr>
             <a:r>
               <a:rPr sz="1100" b="0">
                 <a:solidFill>
@@ -35002,16 +34582,6 @@
               </a:rPr>
               <a:t>Trainee / Field Engineer → </a:t>
             </a:r>
-          </a:p>
-          <a:p>
-            <a:pPr algn="l">
-              <a:lnSpc>
-                <a:spcPct val="110000"/>
-              </a:lnSpc>
-              <a:spcAft>
-                <a:spcPts val="400"/>
-              </a:spcAft>
-            </a:pPr>
             <a:r>
               <a:rPr sz="1000" b="0">
                 <a:solidFill>
@@ -35063,16 +34633,6 @@
               </a:rPr>
               <a:t>Trainer / Training Officer → </a:t>
             </a:r>
-          </a:p>
-          <a:p>
-            <a:pPr algn="l">
-              <a:lnSpc>
-                <a:spcPct val="110000"/>
-              </a:lnSpc>
-              <a:spcAft>
-                <a:spcPts val="400"/>
-              </a:spcAft>
-            </a:pPr>
             <a:r>
               <a:rPr sz="1000" b="0">
                 <a:solidFill>
@@ -35124,16 +34684,6 @@
               </a:rPr>
               <a:t>Admin → </a:t>
             </a:r>
-          </a:p>
-          <a:p>
-            <a:pPr algn="l">
-              <a:lnSpc>
-                <a:spcPct val="110000"/>
-              </a:lnSpc>
-              <a:spcAft>
-                <a:spcPts val="400"/>
-              </a:spcAft>
-            </a:pPr>
             <a:r>
               <a:rPr sz="1000" b="0">
                 <a:solidFill>
@@ -35185,16 +34735,6 @@
               </a:rPr>
               <a:t>Supervisor (extension) → </a:t>
             </a:r>
-          </a:p>
-          <a:p>
-            <a:pPr algn="l">
-              <a:lnSpc>
-                <a:spcPct val="110000"/>
-              </a:lnSpc>
-              <a:spcAft>
-                <a:spcPts val="400"/>
-              </a:spcAft>
-            </a:pPr>
             <a:r>
               <a:rPr sz="1000" b="0">
                 <a:solidFill>

</xml_diff>